<commit_message>
Soutenance DBA : couverture recomposée, mots inventés du modèle effacés, carte du Gabon lisible
Couverture : photo du modèle (main robotique), logos Mundiapolis et IAE de Nice, titre, direction, date, jury et contact en texte éditable. Effacement par aplats des textes IA incrustés dans les illustrations (pages 6, 7, 9, 19) et libellés français reposer en blocs éditables. Carte : Libreville et Estuaire séparés, libellés de provinces sans collision. README mis à jour.

Co-authored-by: arena-agent <297053741+arena-agent@users.noreply.github.com>
</commit_message>
<xml_diff>
--- a/soutenance-dba/export/Soutenance-DBA-MINANG-modele-canva-18.pptx
+++ b/soutenance-dba/export/Soutenance-DBA-MINANG-modele-canva-18.pptx
@@ -4717,7 +4717,7 @@
       <p:grpSpPr/>
       <p:pic>
         <p:nvPicPr>
-          <p:cNvPr id="2" name="Picture 1" descr="fond-01.jpg"/>
+          <p:cNvPr id="2" name="Picture 1" descr="fond-couverture.jpg"/>
           <p:cNvPicPr>
             <a:picLocks noChangeAspect="1"/>
           </p:cNvPicPr>
@@ -4739,119 +4739,343 @@
           </a:prstGeom>
         </p:spPr>
       </p:pic>
-      <p:sp>
-        <p:nvSpPr>
-          <p:cNvPr id="3" name="TextBox 2"/>
-          <p:cNvSpPr txBox="1"/>
-          <p:nvPr/>
-        </p:nvSpPr>
-        <p:spPr>
-          <a:xfrm>
-            <a:off x="7786998" y="393055"/>
-            <a:ext cx="1792112" cy="681715"/>
-          </a:xfrm>
-          <a:prstGeom prst="rect">
-            <a:avLst/>
-          </a:prstGeom>
-          <a:noFill/>
-        </p:spPr>
-        <p:txBody>
-          <a:bodyPr wrap="none" lIns="0" rIns="0" tIns="0" bIns="0" anchor="t">
-            <a:spAutoFit/>
-          </a:bodyPr>
-          <a:lstStyle/>
-          <a:p>
-            <a:pPr algn="l">
-              <a:lnSpc>
-                <a:spcPct val="114583"/>
-              </a:lnSpc>
-            </a:pPr>
-            <a:r>
-              <a:rPr sz="767" b="1">
-                <a:solidFill>
-                  <a:srgbClr val="000000"/>
-                </a:solidFill>
-                <a:latin typeface="Arial"/>
-              </a:rPr>
-              <a:t>Objectif : Analyser comment la</a:t>
-            </a:r>
-          </a:p>
-          <a:p>
-            <a:pPr algn="l">
-              <a:lnSpc>
-                <a:spcPct val="114583"/>
-              </a:lnSpc>
-            </a:pPr>
-            <a:r>
-              <a:rPr sz="767" b="1">
-                <a:solidFill>
-                  <a:srgbClr val="000000"/>
-                </a:solidFill>
-                <a:latin typeface="Arial"/>
-              </a:rPr>
-              <a:t>gouvernance augmentée, intégrant</a:t>
-            </a:r>
-          </a:p>
-          <a:p>
-            <a:pPr algn="l">
-              <a:lnSpc>
-                <a:spcPct val="114583"/>
-              </a:lnSpc>
-            </a:pPr>
-            <a:r>
-              <a:rPr sz="767" b="1">
-                <a:solidFill>
-                  <a:srgbClr val="000000"/>
-                </a:solidFill>
-                <a:latin typeface="Arial"/>
-              </a:rPr>
-              <a:t>IA et intelligence émotionnelle,</a:t>
-            </a:r>
-          </a:p>
-          <a:p>
-            <a:pPr algn="l">
-              <a:lnSpc>
-                <a:spcPct val="114583"/>
-              </a:lnSpc>
-            </a:pPr>
-            <a:r>
-              <a:rPr sz="767" b="1">
-                <a:solidFill>
-                  <a:srgbClr val="000000"/>
-                </a:solidFill>
-                <a:latin typeface="Arial"/>
-              </a:rPr>
-              <a:t>peut répondre aux défis de la</a:t>
-            </a:r>
-          </a:p>
-          <a:p>
-            <a:pPr algn="l">
-              <a:lnSpc>
-                <a:spcPct val="114583"/>
-              </a:lnSpc>
-            </a:pPr>
-            <a:r>
-              <a:rPr sz="767" b="1">
-                <a:solidFill>
-                  <a:srgbClr val="000000"/>
-                </a:solidFill>
-                <a:latin typeface="Arial"/>
-              </a:rPr>
-              <a:t>polycrise gabonaise.</a:t>
-            </a:r>
-          </a:p>
-        </p:txBody>
-      </p:sp>
-      <p:sp>
-        <p:nvSpPr>
-          <p:cNvPr id="4" name="TextBox 3"/>
-          <p:cNvSpPr txBox="1"/>
-          <p:nvPr/>
-        </p:nvSpPr>
-        <p:spPr>
-          <a:xfrm>
-            <a:off x="9659256" y="290610"/>
-            <a:ext cx="2157021" cy="6334390"/>
+      <p:pic>
+        <p:nvPicPr>
+          <p:cNvPr id="3" name="Picture 2" descr="logo-mundiapolis.png"/>
+          <p:cNvPicPr>
+            <a:picLocks noChangeAspect="1"/>
+          </p:cNvPicPr>
+          <p:nvPr/>
+        </p:nvPicPr>
+        <p:blipFill>
+          <a:blip r:embed="rId3"/>
+          <a:stretch>
+            <a:fillRect/>
+          </a:stretch>
+        </p:blipFill>
+        <p:spPr>
+          <a:xfrm>
+            <a:off x="609584" y="440255"/>
+            <a:ext cx="938474" cy="372524"/>
+          </a:xfrm>
+          <a:prstGeom prst="rect">
+            <a:avLst/>
+          </a:prstGeom>
+        </p:spPr>
+      </p:pic>
+      <p:pic>
+        <p:nvPicPr>
+          <p:cNvPr id="4" name="Picture 3" descr="logo-iae-nice.png"/>
+          <p:cNvPicPr>
+            <a:picLocks noChangeAspect="1"/>
+          </p:cNvPicPr>
+          <p:nvPr/>
+        </p:nvPicPr>
+        <p:blipFill>
+          <a:blip r:embed="rId4"/>
+          <a:stretch>
+            <a:fillRect/>
+          </a:stretch>
+        </p:blipFill>
+        <p:spPr>
+          <a:xfrm>
+            <a:off x="1777955" y="440255"/>
+            <a:ext cx="611070" cy="372524"/>
+          </a:xfrm>
+          <a:prstGeom prst="rect">
+            <a:avLst/>
+          </a:prstGeom>
+        </p:spPr>
+      </p:pic>
+      <p:sp>
+        <p:nvSpPr>
+          <p:cNvPr id="5" name="TextBox 4"/>
+          <p:cNvSpPr txBox="1"/>
+          <p:nvPr/>
+        </p:nvSpPr>
+        <p:spPr>
+          <a:xfrm>
+            <a:off x="609584" y="935543"/>
+            <a:ext cx="6017958" cy="152396"/>
+          </a:xfrm>
+          <a:prstGeom prst="rect">
+            <a:avLst/>
+          </a:prstGeom>
+          <a:noFill/>
+        </p:spPr>
+        <p:txBody>
+          <a:bodyPr wrap="none" lIns="0" rIns="0" tIns="0" bIns="0" anchor="t">
+            <a:spAutoFit/>
+          </a:bodyPr>
+          <a:lstStyle/>
+          <a:p>
+            <a:pPr algn="l"/>
+            <a:r>
+              <a:rPr sz="1050" b="1">
+                <a:solidFill>
+                  <a:srgbClr val="1FA8C4"/>
+                </a:solidFill>
+                <a:latin typeface="Arial"/>
+              </a:rPr>
+              <a:t>DOCTORAT DE BUSINESS ADMINISTRATION (DBA)</a:t>
+            </a:r>
+          </a:p>
+        </p:txBody>
+      </p:sp>
+      <p:sp>
+        <p:nvSpPr>
+          <p:cNvPr id="6" name="TextBox 5"/>
+          <p:cNvSpPr txBox="1"/>
+          <p:nvPr/>
+        </p:nvSpPr>
+        <p:spPr>
+          <a:xfrm>
+            <a:off x="609584" y="1223402"/>
+            <a:ext cx="7711249" cy="1015974"/>
+          </a:xfrm>
+          <a:prstGeom prst="rect">
+            <a:avLst/>
+          </a:prstGeom>
+          <a:noFill/>
+        </p:spPr>
+        <p:txBody>
+          <a:bodyPr wrap="none" lIns="0" rIns="0" tIns="0" bIns="0" anchor="t">
+            <a:spAutoFit/>
+          </a:bodyPr>
+          <a:lstStyle/>
+          <a:p>
+            <a:pPr algn="l">
+              <a:lnSpc>
+                <a:spcPct val="100000"/>
+              </a:lnSpc>
+            </a:pPr>
+            <a:r>
+              <a:rPr sz="2000" b="1">
+                <a:solidFill>
+                  <a:srgbClr val="0B2A5B"/>
+                </a:solidFill>
+                <a:latin typeface="Arial"/>
+              </a:rPr>
+              <a:t>Gouvernance augmentée par l'IA et l'IE</a:t>
+            </a:r>
+          </a:p>
+          <a:p>
+            <a:pPr algn="l">
+              <a:lnSpc>
+                <a:spcPct val="100000"/>
+              </a:lnSpc>
+            </a:pPr>
+            <a:r>
+              <a:rPr sz="2000" b="1">
+                <a:solidFill>
+                  <a:srgbClr val="0B2A5B"/>
+                </a:solidFill>
+                <a:latin typeface="Arial"/>
+              </a:rPr>
+              <a:t>dans les EPES au Gabon en situation</a:t>
+            </a:r>
+          </a:p>
+          <a:p>
+            <a:pPr algn="l">
+              <a:lnSpc>
+                <a:spcPct val="100000"/>
+              </a:lnSpc>
+            </a:pPr>
+            <a:r>
+              <a:rPr sz="2000" b="1">
+                <a:solidFill>
+                  <a:srgbClr val="0B2A5B"/>
+                </a:solidFill>
+                <a:latin typeface="Arial"/>
+              </a:rPr>
+              <a:t>de polycrise</a:t>
+            </a:r>
+          </a:p>
+        </p:txBody>
+      </p:sp>
+      <p:sp>
+        <p:nvSpPr>
+          <p:cNvPr id="7" name="TextBox 6"/>
+          <p:cNvSpPr txBox="1"/>
+          <p:nvPr/>
+        </p:nvSpPr>
+        <p:spPr>
+          <a:xfrm>
+            <a:off x="609584" y="2239377"/>
+            <a:ext cx="7711249" cy="203194"/>
+          </a:xfrm>
+          <a:prstGeom prst="rect">
+            <a:avLst/>
+          </a:prstGeom>
+          <a:noFill/>
+        </p:spPr>
+        <p:txBody>
+          <a:bodyPr wrap="none" lIns="0" rIns="0" tIns="0" bIns="0" anchor="t">
+            <a:spAutoFit/>
+          </a:bodyPr>
+          <a:lstStyle/>
+          <a:p>
+            <a:pPr algn="l">
+              <a:lnSpc>
+                <a:spcPct val="110000"/>
+              </a:lnSpc>
+            </a:pPr>
+            <a:r>
+              <a:rPr sz="1200" b="0">
+                <a:solidFill>
+                  <a:srgbClr val="40536E"/>
+                </a:solidFill>
+                <a:latin typeface="Arial"/>
+              </a:rPr>
+              <a:t>Enjeux de performance globale, de responsabilité sociétale et de développement durable</a:t>
+            </a:r>
+          </a:p>
+        </p:txBody>
+      </p:sp>
+      <p:sp>
+        <p:nvSpPr>
+          <p:cNvPr id="8" name="Rectangle 7"/>
+          <p:cNvSpPr/>
+          <p:nvPr/>
+        </p:nvSpPr>
+        <p:spPr>
+          <a:xfrm>
+            <a:off x="609584" y="2539936"/>
+            <a:ext cx="812779" cy="25399"/>
+          </a:xfrm>
+          <a:prstGeom prst="rect">
+            <a:avLst/>
+          </a:prstGeom>
+          <a:solidFill>
+            <a:srgbClr val="1FA8C4"/>
+          </a:solidFill>
+          <a:ln>
+            <a:noFill/>
+          </a:ln>
+          <a:effectLst/>
+        </p:spPr>
+        <p:style>
+          <a:lnRef idx="1">
+            <a:schemeClr val="accent1"/>
+          </a:lnRef>
+          <a:fillRef idx="3">
+            <a:schemeClr val="accent1"/>
+          </a:fillRef>
+          <a:effectRef idx="2">
+            <a:schemeClr val="accent1"/>
+          </a:effectRef>
+          <a:fontRef idx="minor">
+            <a:schemeClr val="lt1"/>
+          </a:fontRef>
+        </p:style>
+        <p:txBody>
+          <a:bodyPr rtlCol="0" anchor="ctr"/>
+          <a:lstStyle/>
+          <a:p>
+            <a:pPr algn="ctr"/>
+          </a:p>
+        </p:txBody>
+      </p:sp>
+      <p:sp>
+        <p:nvSpPr>
+          <p:cNvPr id="9" name="TextBox 8"/>
+          <p:cNvSpPr txBox="1"/>
+          <p:nvPr/>
+        </p:nvSpPr>
+        <p:spPr>
+          <a:xfrm>
+            <a:off x="609584" y="2662700"/>
+            <a:ext cx="5340642" cy="338658"/>
+          </a:xfrm>
+          <a:prstGeom prst="rect">
+            <a:avLst/>
+          </a:prstGeom>
+          <a:noFill/>
+        </p:spPr>
+        <p:txBody>
+          <a:bodyPr wrap="none" lIns="0" rIns="0" tIns="0" bIns="0" anchor="t">
+            <a:spAutoFit/>
+          </a:bodyPr>
+          <a:lstStyle/>
+          <a:p>
+            <a:pPr algn="l"/>
+            <a:r>
+              <a:rPr sz="1850" b="1">
+                <a:solidFill>
+                  <a:srgbClr val="0B2A5B"/>
+                </a:solidFill>
+                <a:latin typeface="Arial"/>
+              </a:rPr>
+              <a:t>Serge Patrick MINANG</a:t>
+            </a:r>
+          </a:p>
+        </p:txBody>
+      </p:sp>
+      <p:sp>
+        <p:nvSpPr>
+          <p:cNvPr id="10" name="TextBox 9"/>
+          <p:cNvSpPr txBox="1"/>
+          <p:nvPr/>
+        </p:nvSpPr>
+        <p:spPr>
+          <a:xfrm>
+            <a:off x="609584" y="3001358"/>
+            <a:ext cx="5509971" cy="423322"/>
+          </a:xfrm>
+          <a:prstGeom prst="rect">
+            <a:avLst/>
+          </a:prstGeom>
+          <a:noFill/>
+        </p:spPr>
+        <p:txBody>
+          <a:bodyPr wrap="none" lIns="0" rIns="0" tIns="0" bIns="0" anchor="t">
+            <a:spAutoFit/>
+          </a:bodyPr>
+          <a:lstStyle/>
+          <a:p>
+            <a:pPr algn="l">
+              <a:lnSpc>
+                <a:spcPct val="140000"/>
+              </a:lnSpc>
+            </a:pPr>
+            <a:r>
+              <a:rPr sz="1000" b="0">
+                <a:solidFill>
+                  <a:srgbClr val="40536E"/>
+                </a:solidFill>
+                <a:latin typeface="Arial"/>
+              </a:rPr>
+              <a:t>Direction de thèse : Pr Jérôme CHABANNE-RIVE</a:t>
+            </a:r>
+          </a:p>
+          <a:p>
+            <a:pPr algn="l">
+              <a:lnSpc>
+                <a:spcPct val="140000"/>
+              </a:lnSpc>
+            </a:pPr>
+            <a:r>
+              <a:rPr sz="1000" b="0">
+                <a:solidFill>
+                  <a:srgbClr val="40536E"/>
+                </a:solidFill>
+                <a:latin typeface="Arial"/>
+              </a:rPr>
+              <a:t>Soutenance publique — 21 décembre 2026</a:t>
+            </a:r>
+          </a:p>
+        </p:txBody>
+      </p:sp>
+      <p:sp>
+        <p:nvSpPr>
+          <p:cNvPr id="11" name="TextBox 10"/>
+          <p:cNvSpPr txBox="1"/>
+          <p:nvPr/>
+        </p:nvSpPr>
+        <p:spPr>
+          <a:xfrm>
+            <a:off x="609584" y="3441613"/>
+            <a:ext cx="6017958" cy="423322"/>
           </a:xfrm>
           <a:prstGeom prst="rect">
             <a:avLst/>
@@ -4866,207 +5090,88 @@
           <a:p>
             <a:pPr algn="l">
               <a:lnSpc>
-                <a:spcPct val="114583"/>
-              </a:lnSpc>
-            </a:pPr>
-            <a:r>
-              <a:rPr sz="799" b="0">
-                <a:solidFill>
-                  <a:srgbClr val="000000"/>
-                </a:solidFill>
-                <a:latin typeface="Arial"/>
-              </a:rPr>
-              <a:t>Doctorant : Serge Patrick MINANG</a:t>
-            </a:r>
-          </a:p>
-          <a:p>
-            <a:pPr algn="l">
-              <a:lnSpc>
-                <a:spcPct val="114583"/>
-              </a:lnSpc>
-            </a:pPr>
-            <a:r>
-              <a:rPr sz="799" b="0">
-                <a:solidFill>
-                  <a:srgbClr val="000000"/>
-                </a:solidFill>
-                <a:latin typeface="Arial"/>
-              </a:rPr>
-              <a:t>Soutenance de thèse doctorale (DBA)</a:t>
-            </a:r>
-          </a:p>
-          <a:p>
-            <a:pPr algn="l">
-              <a:lnSpc>
-                <a:spcPct val="114583"/>
-              </a:lnSpc>
-            </a:pPr>
-            <a:r>
-              <a:rPr sz="799" b="0">
-                <a:solidFill>
-                  <a:srgbClr val="000000"/>
-                </a:solidFill>
-                <a:latin typeface="Arial"/>
-              </a:rPr>
-              <a:t>Directeur de thèse : [à compléter]</a:t>
-            </a:r>
-          </a:p>
-          <a:p>
-            <a:pPr algn="l">
-              <a:lnSpc>
-                <a:spcPct val="114583"/>
-              </a:lnSpc>
-            </a:pPr>
-            <a:r>
-              <a:rPr sz="799" b="0">
-                <a:solidFill>
-                  <a:srgbClr val="000000"/>
-                </a:solidFill>
-                <a:latin typeface="Arial"/>
-              </a:rPr>
-              <a:t>Date de soutenance : [à compléter]</a:t>
-            </a:r>
-          </a:p>
-        </p:txBody>
-      </p:sp>
-      <p:sp>
-        <p:nvSpPr>
-          <p:cNvPr id="5" name="TextBox 4"/>
-          <p:cNvSpPr txBox="1"/>
-          <p:nvPr/>
-        </p:nvSpPr>
-        <p:spPr>
-          <a:xfrm>
-            <a:off x="717532" y="4198164"/>
-            <a:ext cx="1018058" cy="243575"/>
-          </a:xfrm>
-          <a:prstGeom prst="rect">
-            <a:avLst/>
-          </a:prstGeom>
-          <a:noFill/>
-        </p:spPr>
-        <p:txBody>
-          <a:bodyPr wrap="none" lIns="0" rIns="0" tIns="0" bIns="0" anchor="t">
-            <a:spAutoFit/>
-          </a:bodyPr>
-          <a:lstStyle/>
-          <a:p>
-            <a:pPr algn="l">
-              <a:lnSpc>
-                <a:spcPct val="98611"/>
-              </a:lnSpc>
-            </a:pPr>
-            <a:r>
-              <a:rPr sz="751" b="1">
-                <a:solidFill>
-                  <a:srgbClr val="00355E"/>
-                </a:solidFill>
-                <a:latin typeface="Arial"/>
-              </a:rPr>
-              <a:t>Université Paris-Est</a:t>
-            </a:r>
-          </a:p>
-          <a:p>
-            <a:pPr algn="l">
-              <a:lnSpc>
-                <a:spcPct val="98611"/>
-              </a:lnSpc>
-            </a:pPr>
-            <a:r>
-              <a:rPr sz="751" b="1">
-                <a:solidFill>
-                  <a:srgbClr val="00355E"/>
-                </a:solidFill>
-                <a:latin typeface="Arial"/>
-              </a:rPr>
-              <a:t>Créteil</a:t>
-            </a:r>
-          </a:p>
-        </p:txBody>
-      </p:sp>
-      <p:sp>
-        <p:nvSpPr>
-          <p:cNvPr id="6" name="TextBox 5"/>
-          <p:cNvSpPr txBox="1"/>
-          <p:nvPr/>
-        </p:nvSpPr>
-        <p:spPr>
-          <a:xfrm>
-            <a:off x="406389" y="4814732"/>
-            <a:ext cx="8172751" cy="1645827"/>
-          </a:xfrm>
-          <a:prstGeom prst="rect">
-            <a:avLst/>
-          </a:prstGeom>
-          <a:noFill/>
-        </p:spPr>
-        <p:txBody>
-          <a:bodyPr wrap="none" lIns="0" rIns="0" tIns="0" bIns="0" anchor="t">
-            <a:spAutoFit/>
-          </a:bodyPr>
-          <a:lstStyle/>
-          <a:p>
-            <a:pPr algn="l">
-              <a:lnSpc>
-                <a:spcPct val="115473"/>
-              </a:lnSpc>
-            </a:pPr>
-            <a:r>
-              <a:rPr sz="2309" b="0">
-                <a:solidFill>
-                  <a:srgbClr val="00355E"/>
-                </a:solidFill>
-                <a:latin typeface="Arial Black"/>
-              </a:rPr>
-              <a:t>Gouvernance augmentée : articulation de</a:t>
-            </a:r>
-          </a:p>
-          <a:p>
-            <a:pPr algn="l">
-              <a:lnSpc>
-                <a:spcPct val="115473"/>
-              </a:lnSpc>
-            </a:pPr>
-            <a:r>
-              <a:rPr sz="2309" b="0">
-                <a:solidFill>
-                  <a:srgbClr val="00355E"/>
-                </a:solidFill>
-                <a:latin typeface="Arial Black"/>
-              </a:rPr>
-              <a:t>l'intelligence artificielle et de l'intelligence</a:t>
-            </a:r>
-          </a:p>
-          <a:p>
-            <a:pPr algn="l">
-              <a:lnSpc>
-                <a:spcPct val="115473"/>
-              </a:lnSpc>
-            </a:pPr>
-            <a:r>
-              <a:rPr sz="2309" b="0">
-                <a:solidFill>
-                  <a:srgbClr val="00355E"/>
-                </a:solidFill>
-                <a:latin typeface="Arial Black"/>
-              </a:rPr>
-              <a:t>émotionnelle dans le contexte gabonais de</a:t>
-            </a:r>
-          </a:p>
-          <a:p>
-            <a:pPr algn="l">
-              <a:lnSpc>
-                <a:spcPct val="115473"/>
-              </a:lnSpc>
-            </a:pPr>
-            <a:r>
-              <a:rPr sz="2309" b="0">
-                <a:solidFill>
-                  <a:srgbClr val="00355E"/>
-                </a:solidFill>
-                <a:latin typeface="Arial Black"/>
-              </a:rPr>
-              <a:t>polycrise</a:t>
+                <a:spcPct val="140000"/>
+              </a:lnSpc>
+            </a:pPr>
+            <a:r>
+              <a:rPr sz="900" b="1">
+                <a:solidFill>
+                  <a:srgbClr val="1FA8C4"/>
+                </a:solidFill>
+                <a:latin typeface="Arial"/>
+              </a:rPr>
+              <a:t>JURY</a:t>
+            </a:r>
+          </a:p>
+          <a:p>
+            <a:pPr algn="l">
+              <a:lnSpc>
+                <a:spcPct val="140000"/>
+              </a:lnSpc>
+            </a:pPr>
+            <a:r>
+              <a:rPr sz="950" b="0">
+                <a:solidFill>
+                  <a:srgbClr val="40536E"/>
+                </a:solidFill>
+                <a:latin typeface="Arial"/>
+              </a:rPr>
+              <a:t>Marc VALAX (Président) · Jérôme CHABANNE-RIVE (Rapporteur) · Michel PLANE (Suffragant) · Sabrina (Suffragant)</a:t>
+            </a:r>
+          </a:p>
+        </p:txBody>
+      </p:sp>
+      <p:sp>
+        <p:nvSpPr>
+          <p:cNvPr id="12" name="TextBox 11"/>
+          <p:cNvSpPr txBox="1"/>
+          <p:nvPr/>
+        </p:nvSpPr>
+        <p:spPr>
+          <a:xfrm>
+            <a:off x="609584" y="5913818"/>
+            <a:ext cx="6187287" cy="507987"/>
+          </a:xfrm>
+          <a:prstGeom prst="rect">
+            <a:avLst/>
+          </a:prstGeom>
+          <a:noFill/>
+        </p:spPr>
+        <p:txBody>
+          <a:bodyPr wrap="none" lIns="0" rIns="0" tIns="0" bIns="0" anchor="t">
+            <a:spAutoFit/>
+          </a:bodyPr>
+          <a:lstStyle/>
+          <a:p>
+            <a:pPr algn="l">
+              <a:lnSpc>
+                <a:spcPct val="140000"/>
+              </a:lnSpc>
+            </a:pPr>
+            <a:r>
+              <a:rPr sz="900" b="0">
+                <a:solidFill>
+                  <a:srgbClr val="40536E"/>
+                </a:solidFill>
+                <a:latin typeface="Arial"/>
+              </a:rPr>
+              <a:t>contact@upl-gabon.com · +241 02 62 19 78 · Libreville, Gabon</a:t>
+            </a:r>
+          </a:p>
+          <a:p>
+            <a:pPr algn="l">
+              <a:lnSpc>
+                <a:spcPct val="140000"/>
+              </a:lnSpc>
+            </a:pPr>
+            <a:r>
+              <a:rPr sz="850" b="1">
+                <a:solidFill>
+                  <a:srgbClr val="0B2A5B"/>
+                </a:solidFill>
+                <a:latin typeface="Arial"/>
+              </a:rPr>
+              <a:t>EXCELLENCE  •  RESPONSABILITÉ  •  IMPACT</a:t>
             </a:r>
           </a:p>
         </p:txBody>
@@ -8710,6 +8815,84 @@
           </a:p>
         </p:txBody>
       </p:sp>
+      <p:sp>
+        <p:nvSpPr>
+          <p:cNvPr id="9" name="TextBox 8"/>
+          <p:cNvSpPr txBox="1"/>
+          <p:nvPr/>
+        </p:nvSpPr>
+        <p:spPr>
+          <a:xfrm>
+            <a:off x="2446805" y="3567764"/>
+            <a:ext cx="1784731" cy="137156"/>
+          </a:xfrm>
+          <a:prstGeom prst="rect">
+            <a:avLst/>
+          </a:prstGeom>
+          <a:noFill/>
+        </p:spPr>
+        <p:txBody>
+          <a:bodyPr wrap="none" lIns="0" rIns="0" tIns="0" bIns="0" anchor="t">
+            <a:spAutoFit/>
+          </a:bodyPr>
+          <a:lstStyle/>
+          <a:p>
+            <a:pPr algn="ctr">
+              <a:lnSpc>
+                <a:spcPct val="100000"/>
+              </a:lnSpc>
+            </a:pPr>
+            <a:r>
+              <a:rPr sz="1200" b="0">
+                <a:solidFill>
+                  <a:srgbClr val="FFFFFF"/>
+                </a:solidFill>
+                <a:latin typeface="Arial"/>
+              </a:rPr>
+              <a:t>Recherche</a:t>
+            </a:r>
+          </a:p>
+        </p:txBody>
+      </p:sp>
+      <p:sp>
+        <p:nvSpPr>
+          <p:cNvPr id="10" name="TextBox 9"/>
+          <p:cNvSpPr txBox="1"/>
+          <p:nvPr/>
+        </p:nvSpPr>
+        <p:spPr>
+          <a:xfrm>
+            <a:off x="7924601" y="3516965"/>
+            <a:ext cx="1954060" cy="137156"/>
+          </a:xfrm>
+          <a:prstGeom prst="rect">
+            <a:avLst/>
+          </a:prstGeom>
+          <a:noFill/>
+        </p:spPr>
+        <p:txBody>
+          <a:bodyPr wrap="none" lIns="0" rIns="0" tIns="0" bIns="0" anchor="t">
+            <a:spAutoFit/>
+          </a:bodyPr>
+          <a:lstStyle/>
+          <a:p>
+            <a:pPr algn="ctr">
+              <a:lnSpc>
+                <a:spcPct val="100000"/>
+              </a:lnSpc>
+            </a:pPr>
+            <a:r>
+              <a:rPr sz="1200" b="0">
+                <a:solidFill>
+                  <a:srgbClr val="FFFFFF"/>
+                </a:solidFill>
+                <a:latin typeface="Arial"/>
+              </a:rPr>
+              <a:t>Perspectives</a:t>
+            </a:r>
+          </a:p>
+        </p:txBody>
+      </p:sp>
     </p:spTree>
   </p:cSld>
   <p:clrMapOvr>
@@ -10705,7 +10888,7 @@
                 </a:solidFill>
                 <a:latin typeface="Arial"/>
               </a:rPr>
-              <a:t>Comment l'articulation IA–IE transforme-t-elle la gouvernance des EPES gabonais en polycrise, et avec quels effets sur la performance, la RSE et la durabilité ?</a:t>
+              <a:t>Comment l'articulation IA–IE transforme-t-elle la gouvernance des EPES gabonais en polycrise, et quels effets sur la performance, la RSE et la durabilité ?</a:t>
             </a:r>
           </a:p>
         </p:txBody>
@@ -12008,6 +12191,272 @@
           </a:p>
         </p:txBody>
       </p:sp>
+      <p:sp>
+        <p:nvSpPr>
+          <p:cNvPr id="19" name="TextBox 18"/>
+          <p:cNvSpPr txBox="1"/>
+          <p:nvPr/>
+        </p:nvSpPr>
+        <p:spPr>
+          <a:xfrm>
+            <a:off x="897444" y="2520463"/>
+            <a:ext cx="2377382" cy="182875"/>
+          </a:xfrm>
+          <a:prstGeom prst="rect">
+            <a:avLst/>
+          </a:prstGeom>
+          <a:noFill/>
+        </p:spPr>
+        <p:txBody>
+          <a:bodyPr wrap="none" lIns="0" rIns="0" tIns="0" bIns="0" anchor="t">
+            <a:spAutoFit/>
+          </a:bodyPr>
+          <a:lstStyle/>
+          <a:p>
+            <a:pPr algn="ctr">
+              <a:lnSpc>
+                <a:spcPct val="100000"/>
+              </a:lnSpc>
+            </a:pPr>
+            <a:r>
+              <a:rPr sz="1600" b="1">
+                <a:solidFill>
+                  <a:srgbClr val="FFFFFF"/>
+                </a:solidFill>
+                <a:latin typeface="Arial"/>
+              </a:rPr>
+              <a:t>Relation d'agence</a:t>
+            </a:r>
+          </a:p>
+        </p:txBody>
+      </p:sp>
+      <p:sp>
+        <p:nvSpPr>
+          <p:cNvPr id="20" name="TextBox 19"/>
+          <p:cNvSpPr txBox="1"/>
+          <p:nvPr/>
+        </p:nvSpPr>
+        <p:spPr>
+          <a:xfrm>
+            <a:off x="905910" y="3178413"/>
+            <a:ext cx="1107414" cy="120011"/>
+          </a:xfrm>
+          <a:prstGeom prst="rect">
+            <a:avLst/>
+          </a:prstGeom>
+          <a:noFill/>
+        </p:spPr>
+        <p:txBody>
+          <a:bodyPr wrap="none" lIns="0" rIns="0" tIns="0" bIns="0" anchor="t">
+            <a:spAutoFit/>
+          </a:bodyPr>
+          <a:lstStyle/>
+          <a:p>
+            <a:pPr algn="ctr">
+              <a:lnSpc>
+                <a:spcPct val="100000"/>
+              </a:lnSpc>
+            </a:pPr>
+            <a:r>
+              <a:rPr sz="1050" b="1">
+                <a:solidFill>
+                  <a:srgbClr val="0B2F5C"/>
+                </a:solidFill>
+                <a:latin typeface="Arial"/>
+              </a:rPr>
+              <a:t>Mandant</a:t>
+            </a:r>
+          </a:p>
+        </p:txBody>
+      </p:sp>
+      <p:sp>
+        <p:nvSpPr>
+          <p:cNvPr id="21" name="TextBox 20"/>
+          <p:cNvSpPr txBox="1"/>
+          <p:nvPr/>
+        </p:nvSpPr>
+        <p:spPr>
+          <a:xfrm>
+            <a:off x="2243610" y="3178413"/>
+            <a:ext cx="1192079" cy="120011"/>
+          </a:xfrm>
+          <a:prstGeom prst="rect">
+            <a:avLst/>
+          </a:prstGeom>
+          <a:noFill/>
+        </p:spPr>
+        <p:txBody>
+          <a:bodyPr wrap="none" lIns="0" rIns="0" tIns="0" bIns="0" anchor="t">
+            <a:spAutoFit/>
+          </a:bodyPr>
+          <a:lstStyle/>
+          <a:p>
+            <a:pPr algn="ctr">
+              <a:lnSpc>
+                <a:spcPct val="100000"/>
+              </a:lnSpc>
+            </a:pPr>
+            <a:r>
+              <a:rPr sz="1050" b="1">
+                <a:solidFill>
+                  <a:srgbClr val="0B2F5C"/>
+                </a:solidFill>
+                <a:latin typeface="Arial"/>
+              </a:rPr>
+              <a:t>Mandataire</a:t>
+            </a:r>
+          </a:p>
+        </p:txBody>
+      </p:sp>
+      <p:sp>
+        <p:nvSpPr>
+          <p:cNvPr id="22" name="TextBox 21"/>
+          <p:cNvSpPr txBox="1"/>
+          <p:nvPr/>
+        </p:nvSpPr>
+        <p:spPr>
+          <a:xfrm>
+            <a:off x="5765655" y="3615917"/>
+            <a:ext cx="802622" cy="108582"/>
+          </a:xfrm>
+          <a:prstGeom prst="rect">
+            <a:avLst/>
+          </a:prstGeom>
+          <a:noFill/>
+        </p:spPr>
+        <p:txBody>
+          <a:bodyPr wrap="none" lIns="0" rIns="0" tIns="0" bIns="0" anchor="t">
+            <a:spAutoFit/>
+          </a:bodyPr>
+          <a:lstStyle/>
+          <a:p>
+            <a:pPr algn="ctr">
+              <a:lnSpc>
+                <a:spcPct val="100000"/>
+              </a:lnSpc>
+            </a:pPr>
+            <a:r>
+              <a:rPr sz="950" b="1">
+                <a:solidFill>
+                  <a:srgbClr val="FFFFFF"/>
+                </a:solidFill>
+                <a:latin typeface="Arial"/>
+              </a:rPr>
+              <a:t>Interaction</a:t>
+            </a:r>
+          </a:p>
+        </p:txBody>
+      </p:sp>
+      <p:sp>
+        <p:nvSpPr>
+          <p:cNvPr id="23" name="TextBox 22"/>
+          <p:cNvSpPr txBox="1"/>
+          <p:nvPr/>
+        </p:nvSpPr>
+        <p:spPr>
+          <a:xfrm>
+            <a:off x="8957509" y="3668726"/>
+            <a:ext cx="1209012" cy="240023"/>
+          </a:xfrm>
+          <a:prstGeom prst="rect">
+            <a:avLst/>
+          </a:prstGeom>
+          <a:noFill/>
+        </p:spPr>
+        <p:txBody>
+          <a:bodyPr wrap="none" lIns="0" rIns="0" tIns="0" bIns="0" anchor="t">
+            <a:spAutoFit/>
+          </a:bodyPr>
+          <a:lstStyle/>
+          <a:p>
+            <a:pPr algn="ctr">
+              <a:lnSpc>
+                <a:spcPct val="100000"/>
+              </a:lnSpc>
+            </a:pPr>
+            <a:r>
+              <a:rPr sz="1050" b="1">
+                <a:solidFill>
+                  <a:srgbClr val="FFFFFF"/>
+                </a:solidFill>
+                <a:latin typeface="Arial"/>
+              </a:rPr>
+              <a:t>Intelligence</a:t>
+            </a:r>
+          </a:p>
+          <a:p>
+            <a:pPr algn="ctr">
+              <a:lnSpc>
+                <a:spcPct val="100000"/>
+              </a:lnSpc>
+            </a:pPr>
+            <a:r>
+              <a:rPr sz="1050" b="1">
+                <a:solidFill>
+                  <a:srgbClr val="FFFFFF"/>
+                </a:solidFill>
+                <a:latin typeface="Arial"/>
+              </a:rPr>
+              <a:t>artificielle</a:t>
+            </a:r>
+          </a:p>
+        </p:txBody>
+      </p:sp>
+      <p:sp>
+        <p:nvSpPr>
+          <p:cNvPr id="24" name="TextBox 23"/>
+          <p:cNvSpPr txBox="1"/>
+          <p:nvPr/>
+        </p:nvSpPr>
+        <p:spPr>
+          <a:xfrm>
+            <a:off x="10354474" y="3516330"/>
+            <a:ext cx="1005817" cy="240023"/>
+          </a:xfrm>
+          <a:prstGeom prst="rect">
+            <a:avLst/>
+          </a:prstGeom>
+          <a:noFill/>
+        </p:spPr>
+        <p:txBody>
+          <a:bodyPr wrap="none" lIns="0" rIns="0" tIns="0" bIns="0" anchor="t">
+            <a:spAutoFit/>
+          </a:bodyPr>
+          <a:lstStyle/>
+          <a:p>
+            <a:pPr algn="ctr">
+              <a:lnSpc>
+                <a:spcPct val="100000"/>
+              </a:lnSpc>
+            </a:pPr>
+            <a:r>
+              <a:rPr sz="1050" b="1">
+                <a:solidFill>
+                  <a:srgbClr val="FFFFFF"/>
+                </a:solidFill>
+                <a:latin typeface="Arial"/>
+              </a:rPr>
+              <a:t>Intelligence</a:t>
+            </a:r>
+          </a:p>
+          <a:p>
+            <a:pPr algn="ctr">
+              <a:lnSpc>
+                <a:spcPct val="100000"/>
+              </a:lnSpc>
+            </a:pPr>
+            <a:r>
+              <a:rPr sz="1050" b="1">
+                <a:solidFill>
+                  <a:srgbClr val="FFFFFF"/>
+                </a:solidFill>
+                <a:latin typeface="Arial"/>
+              </a:rPr>
+              <a:t>émotionnelle</a:t>
+            </a:r>
+          </a:p>
+        </p:txBody>
+      </p:sp>
     </p:spTree>
   </p:cSld>
   <p:clrMapOvr>
@@ -12585,6 +13034,382 @@
           </a:p>
         </p:txBody>
       </p:sp>
+      <p:sp>
+        <p:nvSpPr>
+          <p:cNvPr id="16" name="TextBox 15"/>
+          <p:cNvSpPr txBox="1"/>
+          <p:nvPr/>
+        </p:nvSpPr>
+        <p:spPr>
+          <a:xfrm>
+            <a:off x="1380032" y="3555487"/>
+            <a:ext cx="1446072" cy="297172"/>
+          </a:xfrm>
+          <a:prstGeom prst="rect">
+            <a:avLst/>
+          </a:prstGeom>
+          <a:noFill/>
+        </p:spPr>
+        <p:txBody>
+          <a:bodyPr wrap="none" lIns="0" rIns="0" tIns="0" bIns="0" anchor="t">
+            <a:spAutoFit/>
+          </a:bodyPr>
+          <a:lstStyle/>
+          <a:p>
+            <a:pPr algn="ctr">
+              <a:lnSpc>
+                <a:spcPct val="100000"/>
+              </a:lnSpc>
+            </a:pPr>
+            <a:r>
+              <a:rPr sz="1300" b="1">
+                <a:solidFill>
+                  <a:srgbClr val="00355E"/>
+                </a:solidFill>
+                <a:latin typeface="Arial"/>
+              </a:rPr>
+              <a:t>Résilience</a:t>
+            </a:r>
+          </a:p>
+          <a:p>
+            <a:pPr algn="ctr">
+              <a:lnSpc>
+                <a:spcPct val="100000"/>
+              </a:lnSpc>
+            </a:pPr>
+            <a:r>
+              <a:rPr sz="1300" b="1">
+                <a:solidFill>
+                  <a:srgbClr val="00355E"/>
+                </a:solidFill>
+                <a:latin typeface="Arial"/>
+              </a:rPr>
+              <a:t>organisationnelle</a:t>
+            </a:r>
+          </a:p>
+        </p:txBody>
+      </p:sp>
+      <p:sp>
+        <p:nvSpPr>
+          <p:cNvPr id="17" name="TextBox 16"/>
+          <p:cNvSpPr txBox="1"/>
+          <p:nvPr/>
+        </p:nvSpPr>
+        <p:spPr>
+          <a:xfrm>
+            <a:off x="5062940" y="2498133"/>
+            <a:ext cx="2123389" cy="142871"/>
+          </a:xfrm>
+          <a:prstGeom prst="rect">
+            <a:avLst/>
+          </a:prstGeom>
+          <a:noFill/>
+        </p:spPr>
+        <p:txBody>
+          <a:bodyPr wrap="none" lIns="0" rIns="0" tIns="0" bIns="0" anchor="t">
+            <a:spAutoFit/>
+          </a:bodyPr>
+          <a:lstStyle/>
+          <a:p>
+            <a:pPr algn="ctr">
+              <a:lnSpc>
+                <a:spcPct val="100000"/>
+              </a:lnSpc>
+            </a:pPr>
+            <a:r>
+              <a:rPr sz="1250" b="1">
+                <a:solidFill>
+                  <a:srgbClr val="00355E"/>
+                </a:solidFill>
+                <a:latin typeface="Arial"/>
+              </a:rPr>
+              <a:t>Capacités dynamiques</a:t>
+            </a:r>
+          </a:p>
+        </p:txBody>
+      </p:sp>
+      <p:sp>
+        <p:nvSpPr>
+          <p:cNvPr id="18" name="TextBox 17"/>
+          <p:cNvSpPr txBox="1"/>
+          <p:nvPr/>
+        </p:nvSpPr>
+        <p:spPr>
+          <a:xfrm>
+            <a:off x="4673483" y="3652217"/>
+            <a:ext cx="684091" cy="171445"/>
+          </a:xfrm>
+          <a:prstGeom prst="rect">
+            <a:avLst/>
+          </a:prstGeom>
+          <a:noFill/>
+        </p:spPr>
+        <p:txBody>
+          <a:bodyPr wrap="none" lIns="0" rIns="0" tIns="0" bIns="0" anchor="t">
+            <a:spAutoFit/>
+          </a:bodyPr>
+          <a:lstStyle/>
+          <a:p>
+            <a:pPr algn="ctr">
+              <a:lnSpc>
+                <a:spcPct val="100000"/>
+              </a:lnSpc>
+            </a:pPr>
+            <a:r>
+              <a:rPr sz="750" b="1">
+                <a:solidFill>
+                  <a:srgbClr val="00355E"/>
+                </a:solidFill>
+                <a:latin typeface="Arial"/>
+              </a:rPr>
+              <a:t>Détecter</a:t>
+            </a:r>
+          </a:p>
+          <a:p>
+            <a:pPr algn="ctr">
+              <a:lnSpc>
+                <a:spcPct val="100000"/>
+              </a:lnSpc>
+            </a:pPr>
+            <a:r>
+              <a:rPr sz="750" b="1">
+                <a:solidFill>
+                  <a:srgbClr val="00355E"/>
+                </a:solidFill>
+                <a:latin typeface="Arial"/>
+              </a:rPr>
+              <a:t>saisir</a:t>
+            </a:r>
+          </a:p>
+        </p:txBody>
+      </p:sp>
+      <p:sp>
+        <p:nvSpPr>
+          <p:cNvPr id="19" name="TextBox 18"/>
+          <p:cNvSpPr txBox="1"/>
+          <p:nvPr/>
+        </p:nvSpPr>
+        <p:spPr>
+          <a:xfrm>
+            <a:off x="6620767" y="3695078"/>
+            <a:ext cx="938085" cy="85722"/>
+          </a:xfrm>
+          <a:prstGeom prst="rect">
+            <a:avLst/>
+          </a:prstGeom>
+          <a:noFill/>
+        </p:spPr>
+        <p:txBody>
+          <a:bodyPr wrap="none" lIns="0" rIns="0" tIns="0" bIns="0" anchor="t">
+            <a:spAutoFit/>
+          </a:bodyPr>
+          <a:lstStyle/>
+          <a:p>
+            <a:pPr algn="ctr">
+              <a:lnSpc>
+                <a:spcPct val="100000"/>
+              </a:lnSpc>
+            </a:pPr>
+            <a:r>
+              <a:rPr sz="750" b="1">
+                <a:solidFill>
+                  <a:srgbClr val="00355E"/>
+                </a:solidFill>
+                <a:latin typeface="Arial"/>
+              </a:rPr>
+              <a:t>Reconfigurer</a:t>
+            </a:r>
+          </a:p>
+        </p:txBody>
+      </p:sp>
+      <p:sp>
+        <p:nvSpPr>
+          <p:cNvPr id="20" name="TextBox 19"/>
+          <p:cNvSpPr txBox="1"/>
+          <p:nvPr/>
+        </p:nvSpPr>
+        <p:spPr>
+          <a:xfrm>
+            <a:off x="1888019" y="2622696"/>
+            <a:ext cx="430098" cy="80007"/>
+          </a:xfrm>
+          <a:prstGeom prst="rect">
+            <a:avLst/>
+          </a:prstGeom>
+          <a:noFill/>
+        </p:spPr>
+        <p:txBody>
+          <a:bodyPr wrap="none" lIns="0" rIns="0" tIns="0" bIns="0" anchor="t">
+            <a:spAutoFit/>
+          </a:bodyPr>
+          <a:lstStyle/>
+          <a:p>
+            <a:pPr algn="ctr">
+              <a:lnSpc>
+                <a:spcPct val="100000"/>
+              </a:lnSpc>
+            </a:pPr>
+            <a:r>
+              <a:rPr sz="700" b="1">
+                <a:solidFill>
+                  <a:srgbClr val="FFFFFF"/>
+                </a:solidFill>
+                <a:latin typeface="Arial"/>
+              </a:rPr>
+              <a:t>Absorber</a:t>
+            </a:r>
+          </a:p>
+        </p:txBody>
+      </p:sp>
+      <p:sp>
+        <p:nvSpPr>
+          <p:cNvPr id="21" name="TextBox 20"/>
+          <p:cNvSpPr txBox="1"/>
+          <p:nvPr/>
+        </p:nvSpPr>
+        <p:spPr>
+          <a:xfrm>
+            <a:off x="1888019" y="4620779"/>
+            <a:ext cx="480896" cy="80007"/>
+          </a:xfrm>
+          <a:prstGeom prst="rect">
+            <a:avLst/>
+          </a:prstGeom>
+          <a:noFill/>
+        </p:spPr>
+        <p:txBody>
+          <a:bodyPr wrap="none" lIns="0" rIns="0" tIns="0" bIns="0" anchor="t">
+            <a:spAutoFit/>
+          </a:bodyPr>
+          <a:lstStyle/>
+          <a:p>
+            <a:pPr algn="ctr">
+              <a:lnSpc>
+                <a:spcPct val="100000"/>
+              </a:lnSpc>
+            </a:pPr>
+            <a:r>
+              <a:rPr sz="700" b="1">
+                <a:solidFill>
+                  <a:srgbClr val="FFFFFF"/>
+                </a:solidFill>
+                <a:latin typeface="Arial"/>
+              </a:rPr>
+              <a:t>S'adapter</a:t>
+            </a:r>
+          </a:p>
+        </p:txBody>
+      </p:sp>
+      <p:sp>
+        <p:nvSpPr>
+          <p:cNvPr id="22" name="TextBox 21"/>
+          <p:cNvSpPr txBox="1"/>
+          <p:nvPr/>
+        </p:nvSpPr>
+        <p:spPr>
+          <a:xfrm>
+            <a:off x="8957509" y="3282444"/>
+            <a:ext cx="870353" cy="182875"/>
+          </a:xfrm>
+          <a:prstGeom prst="rect">
+            <a:avLst/>
+          </a:prstGeom>
+          <a:noFill/>
+        </p:spPr>
+        <p:txBody>
+          <a:bodyPr wrap="none" lIns="0" rIns="0" tIns="0" bIns="0" anchor="t">
+            <a:spAutoFit/>
+          </a:bodyPr>
+          <a:lstStyle/>
+          <a:p>
+            <a:pPr algn="ctr">
+              <a:lnSpc>
+                <a:spcPct val="100000"/>
+              </a:lnSpc>
+            </a:pPr>
+            <a:r>
+              <a:rPr sz="800" b="1">
+                <a:solidFill>
+                  <a:srgbClr val="0B2F5C"/>
+                </a:solidFill>
+                <a:latin typeface="Arial"/>
+              </a:rPr>
+              <a:t>Intelligence</a:t>
+            </a:r>
+          </a:p>
+          <a:p>
+            <a:pPr algn="ctr">
+              <a:lnSpc>
+                <a:spcPct val="100000"/>
+              </a:lnSpc>
+            </a:pPr>
+            <a:r>
+              <a:rPr sz="800" b="1">
+                <a:solidFill>
+                  <a:srgbClr val="0B2F5C"/>
+                </a:solidFill>
+                <a:latin typeface="Arial"/>
+              </a:rPr>
+              <a:t>émotionnelle</a:t>
+            </a:r>
+          </a:p>
+        </p:txBody>
+      </p:sp>
+      <p:sp>
+        <p:nvSpPr>
+          <p:cNvPr id="23" name="TextBox 22"/>
+          <p:cNvSpPr txBox="1"/>
+          <p:nvPr/>
+        </p:nvSpPr>
+        <p:spPr>
+          <a:xfrm>
+            <a:off x="10616934" y="3273978"/>
+            <a:ext cx="904219" cy="182875"/>
+          </a:xfrm>
+          <a:prstGeom prst="rect">
+            <a:avLst/>
+          </a:prstGeom>
+          <a:noFill/>
+        </p:spPr>
+        <p:txBody>
+          <a:bodyPr wrap="none" lIns="0" rIns="0" tIns="0" bIns="0" anchor="t">
+            <a:spAutoFit/>
+          </a:bodyPr>
+          <a:lstStyle/>
+          <a:p>
+            <a:pPr algn="ctr">
+              <a:lnSpc>
+                <a:spcPct val="100000"/>
+              </a:lnSpc>
+            </a:pPr>
+            <a:r>
+              <a:rPr sz="800" b="1">
+                <a:solidFill>
+                  <a:srgbClr val="0B2F5C"/>
+                </a:solidFill>
+                <a:latin typeface="Arial"/>
+              </a:rPr>
+              <a:t>Gouvernance</a:t>
+            </a:r>
+          </a:p>
+          <a:p>
+            <a:pPr algn="ctr">
+              <a:lnSpc>
+                <a:spcPct val="100000"/>
+              </a:lnSpc>
+            </a:pPr>
+            <a:r>
+              <a:rPr sz="800" b="1">
+                <a:solidFill>
+                  <a:srgbClr val="0B2F5C"/>
+                </a:solidFill>
+                <a:latin typeface="Arial"/>
+              </a:rPr>
+              <a:t>résiliente</a:t>
+            </a:r>
+          </a:p>
+        </p:txBody>
+      </p:sp>
     </p:spTree>
   </p:cSld>
   <p:clrMapOvr>
@@ -14002,6 +14827,61 @@
                 <a:latin typeface="Arial"/>
               </a:rPr>
               <a:t>polycrise.</a:t>
+            </a:r>
+          </a:p>
+        </p:txBody>
+      </p:sp>
+      <p:sp>
+        <p:nvSpPr>
+          <p:cNvPr id="9" name="TextBox 8"/>
+          <p:cNvSpPr txBox="1"/>
+          <p:nvPr/>
+        </p:nvSpPr>
+        <p:spPr>
+          <a:xfrm>
+            <a:off x="5130671" y="4630727"/>
+            <a:ext cx="1784731" cy="297172"/>
+          </a:xfrm>
+          <a:prstGeom prst="rect">
+            <a:avLst/>
+          </a:prstGeom>
+          <a:noFill/>
+        </p:spPr>
+        <p:txBody>
+          <a:bodyPr wrap="none" lIns="0" rIns="0" tIns="0" bIns="0" anchor="t">
+            <a:spAutoFit/>
+          </a:bodyPr>
+          <a:lstStyle/>
+          <a:p>
+            <a:pPr algn="ctr">
+              <a:lnSpc>
+                <a:spcPct val="100000"/>
+              </a:lnSpc>
+            </a:pPr>
+            <a:r>
+              <a:rPr sz="1300" b="1">
+                <a:solidFill>
+                  <a:srgbClr val="FFFFFF"/>
+                </a:solidFill>
+                <a:latin typeface="Arial"/>
+              </a:rPr>
+              <a:t>Gouvernance</a:t>
+            </a:r>
+          </a:p>
+          <a:p>
+            <a:pPr algn="ctr">
+              <a:lnSpc>
+                <a:spcPct val="100000"/>
+              </a:lnSpc>
+            </a:pPr>
+            <a:r>
+              <a:rPr sz="1300" b="1">
+                <a:solidFill>
+                  <a:srgbClr val="FFFFFF"/>
+                </a:solidFill>
+                <a:latin typeface="Arial"/>
+              </a:rPr>
+              <a:t>augmentée</a:t>
             </a:r>
           </a:p>
         </p:txBody>

</xml_diff>